<commit_message>
Add multicollinearity analysis (VIF): drop derived/redundant vars from classifier
- VIF on 10 financial features (Maximum deductible amount VIF=204, Operating Income VIF=182)
- classification now uses 8-feature cleaned set (stable coefficients, same CV AUC 0.852)
- updated REPORT.md (multicollinearity section + Task B) and slide 7
</commit_message>
<xml_diff>
--- a/artifacts/IFCS_2026_presentation.pptx
+++ b/artifacts/IFCS_2026_presentation.pptx
@@ -1358,6 +1358,28 @@
                   <a:srgbClr val="1F3A5F"/>
                 </a:solidFill>
               </a:rPr>
+              <a:t>Cleaning.</a:t>
+            </a:r>
+          </a:p>
+          <a:p>
+            <a:pPr/>
+            <a:r>
+              <a:rPr lang="en-US" sz="1600" b="0" i="0">
+                <a:solidFill>
+                  <a:srgbClr val="555555"/>
+                </a:solidFill>
+              </a:rPr>
+              <a:t>Dropped 2 collinear derived vars (VIF 182-204) so coefficients are stable.</a:t>
+            </a:r>
+          </a:p>
+          <a:p>
+            <a:pPr/>
+            <a:r>
+              <a:rPr lang="en-US" sz="1600" b="1" i="0">
+                <a:solidFill>
+                  <a:srgbClr val="1F3A5F"/>
+                </a:solidFill>
+              </a:rPr>
               <a:t>Validation.</a:t>
             </a:r>
           </a:p>
@@ -1435,7 +1457,7 @@
                   <a:srgbClr val="555555"/>
                 </a:solidFill>
               </a:rPr>
-              <a:t>Operating Income, Net income, Total financial expenses, Maximum deductible amount.</a:t>
+              <a:t>Operating Income, Net income, Total financial expenses, Operating cash flow.</a:t>
             </a:r>
           </a:p>
         </p:txBody>

</xml_diff>

<commit_message>
Data cleaning + variable selection (contextual outlier removal)
- remove 85 incongruent outliers (3*IQR on log1p + correlated vars inside fence) + 3 Sales<=0
- 13956 -> 13871 rows (0.6%); same CV AUC 0.852 (removed rows were noise)
- documented cleaning/feature-selection in REPORT.md; added cleaning slide
</commit_message>
<xml_diff>
--- a/artifacts/IFCS_2026_presentation.pptx
+++ b/artifacts/IFCS_2026_presentation.pptx
@@ -13,6 +13,7 @@
     <p:sldId id="261" r:id="rId8"/>
     <p:sldId id="262" r:id="rId9"/>
     <p:sldId id="263" r:id="rId10"/>
+    <p:sldId id="264" r:id="rId11"/>
   </p:sldIdLst>
   <p:sldSz cx="12192000" cy="6858000" type="screen16x9"/>
   <p:notesSz cx="6858000" cy="9144000"/>
@@ -192,7 +193,7 @@
                   <a:srgbClr val="9FB6CC"/>
                 </a:solidFill>
               </a:rPr>
-              <a:t>~13,956 firms (FY2023)  |  distress rate 10.8%  |  14 financial &amp; structural features</a:t>
+              <a:t>~13,871 firms (FY2023)  |  distress rate 10.8%  |  14 financial &amp; structural features</a:t>
             </a:r>
           </a:p>
         </p:txBody>
@@ -346,7 +347,7 @@
                   <a:srgbClr val="555555"/>
                 </a:solidFill>
               </a:rPr>
-              <a:t>One row per SME, 13,956 firms, monetary values in kEUR, geography at province level.</a:t>
+              <a:t>One row per SME, 13,871 firms, monetary values in kEUR, geography at province level.</a:t>
             </a:r>
           </a:p>
           <a:p>
@@ -709,7 +710,7 @@
                   <a:srgbClr val="FFFFFF"/>
                 </a:solidFill>
               </a:rPr>
-              <a:t>Task A - Clustering Method</a:t>
+              <a:t>Cleaning &amp; Feature Selection</a:t>
             </a:r>
           </a:p>
         </p:txBody>
@@ -736,40 +737,84 @@
                   <a:srgbClr val="1F3A5F"/>
                 </a:solidFill>
               </a:rPr>
-              <a:t>Algorithm.</a:t>
-            </a:r>
-          </a:p>
-          <a:p>
-            <a:pPr/>
-            <a:r>
-              <a:rPr lang="en-US" sz="1600" b="0" i="0">
-                <a:solidFill>
-                  <a:srgbClr val="555555"/>
-                </a:solidFill>
-              </a:rPr>
-              <a:t>K-Means on standardized, log-transformed features.</a:t>
-            </a:r>
-          </a:p>
-          <a:p>
-            <a:pPr/>
-            <a:r>
-              <a:rPr lang="en-US" sz="1600" b="1" i="0">
-                <a:solidFill>
-                  <a:srgbClr val="1F3A5F"/>
-                </a:solidFill>
-              </a:rPr>
-              <a:t>Choosing k.</a:t>
-            </a:r>
-          </a:p>
-          <a:p>
-            <a:pPr/>
-            <a:r>
-              <a:rPr lang="en-US" sz="1600" b="0" i="0">
-                <a:solidFill>
-                  <a:srgbClr val="555555"/>
-                </a:solidFill>
-              </a:rPr>
-              <a:t>Silhouette over k=2..8 (max at k=2); K=5 selected for profiling granularity.</a:t>
+              <a:t>Rows.</a:t>
+            </a:r>
+          </a:p>
+          <a:p>
+            <a:pPr/>
+            <a:r>
+              <a:rPr lang="en-US" sz="1600" b="0" i="0">
+                <a:solidFill>
+                  <a:srgbClr val="555555"/>
+                </a:solidFill>
+              </a:rPr>
+              <a:t>13,956 -&gt; 13,871: removed 3 impossible (Sales&lt;=0) + 85 incongruent outliers.</a:t>
+            </a:r>
+          </a:p>
+          <a:p>
+            <a:pPr/>
+            <a:r>
+              <a:rPr lang="en-US" sz="1600" b="1" i="0">
+                <a:solidFill>
+                  <a:srgbClr val="1F3A5F"/>
+                </a:solidFill>
+              </a:rPr>
+              <a:t>Contextual rule.</a:t>
+            </a:r>
+          </a:p>
+          <a:p>
+            <a:pPr/>
+            <a:r>
+              <a:rPr lang="en-US" sz="1600" b="0" i="0">
+                <a:solidFill>
+                  <a:srgbClr val="555555"/>
+                </a:solidFill>
+              </a:rPr>
+              <a:t>Drop extreme only if its correlated vars are normal (erroneous); keep coherent extremes (real distress).</a:t>
+            </a:r>
+          </a:p>
+          <a:p>
+            <a:pPr/>
+            <a:r>
+              <a:rPr lang="en-US" sz="1600" b="1" i="0">
+                <a:solidFill>
+                  <a:srgbClr val="1F3A5F"/>
+                </a:solidFill>
+              </a:rPr>
+              <a:t>Multicollinearity.</a:t>
+            </a:r>
+          </a:p>
+          <a:p>
+            <a:pPr/>
+            <a:r>
+              <a:rPr lang="en-US" sz="1600" b="0" i="0">
+                <a:solidFill>
+                  <a:srgbClr val="555555"/>
+                </a:solidFill>
+              </a:rPr>
+              <a:t>VIF up to 204 (Max deductible ~ Operating Income); dropped 2 derived vars from the model.</a:t>
+            </a:r>
+          </a:p>
+          <a:p>
+            <a:pPr/>
+            <a:r>
+              <a:rPr lang="en-US" sz="1600" b="1" i="0">
+                <a:solidFill>
+                  <a:srgbClr val="1F3A5F"/>
+                </a:solidFill>
+              </a:rPr>
+              <a:t>Classifier features.</a:t>
+            </a:r>
+          </a:p>
+          <a:p>
+            <a:pPr/>
+            <a:r>
+              <a:rPr lang="en-US" sz="1600" b="0" i="0">
+                <a:solidFill>
+                  <a:srgbClr val="555555"/>
+                </a:solidFill>
+              </a:rPr>
+              <a:t>8 cleaned vars (Sales, Employees, Net/Op income, FinExp, OpCF, Taxes, Alert).</a:t>
             </a:r>
           </a:p>
           <a:p>
@@ -791,51 +836,11 @@
                   <a:srgbClr val="555555"/>
                 </a:solidFill>
               </a:rPr>
-              <a:t>K = 5 clusters; silhouette at K=5 = 0.228.</a:t>
-            </a:r>
-          </a:p>
-          <a:p>
-            <a:pPr/>
-            <a:r>
-              <a:rPr lang="en-US" sz="1600" b="1" i="0">
-                <a:solidFill>
-                  <a:srgbClr val="1F3A5F"/>
-                </a:solidFill>
-              </a:rPr>
-              <a:t>Trade-off.</a:t>
-            </a:r>
-          </a:p>
-          <a:p>
-            <a:pPr/>
-            <a:r>
-              <a:rPr lang="en-US" sz="1600" b="0" i="0">
-                <a:solidFill>
-                  <a:srgbClr val="555555"/>
-                </a:solidFill>
-              </a:rPr>
-              <a:t>Separation vs interpretability: 5 segments are economically distinguishable.</a:t>
-            </a:r>
-          </a:p>
-        </p:txBody>
-      </p:sp>
-      <p:pic>
-        <p:nvPicPr>
-          <p:cNvPr id="3" name="pic"/>
-          <p:cNvPicPr/>
-          <p:nvPr/>
-        </p:nvPicPr>
-        <p:blipFill>
-          <a:blip r:embed="rId1"/>
-          <a:stretch>
-            <a:fillRect/>
-          </a:stretch>
-        </p:blipFill>
-        <p:spPr>
-          <a:off x="6400800" y="1463040"/>
-          <a:ext cx="5486400" cy="3086100"/>
-          <a:noFill/>
-        </p:spPr>
-      </p:pic>
+              <a:t>Same CV AUC (0.852) - removed rows were noise, not signal.</a:t>
+            </a:r>
+          </a:p>
+        </p:txBody>
+      </p:sp>
     </p:spTree>
   </p:cSld>
   <p:clrMapOvr>
@@ -903,7 +908,7 @@
                   <a:srgbClr val="FFFFFF"/>
                 </a:solidFill>
               </a:rPr>
-              <a:t>Task A - Cluster Profiles</a:t>
+              <a:t>Task A - Clustering Method</a:t>
             </a:r>
           </a:p>
         </p:txBody>
@@ -930,106 +935,84 @@
                   <a:srgbClr val="1F3A5F"/>
                 </a:solidFill>
               </a:rPr>
-              <a:t>Cluster 0 (n=3811)</a:t>
-            </a:r>
-          </a:p>
-          <a:p>
-            <a:pPr/>
-            <a:r>
-              <a:rPr lang="en-US" sz="1600" b="0" i="0">
-                <a:solidFill>
-                  <a:srgbClr val="555555"/>
-                </a:solidFill>
-              </a:rPr>
-              <a:t>distress rate 7.0%</a:t>
-            </a:r>
-          </a:p>
-          <a:p>
-            <a:pPr/>
-            <a:r>
-              <a:rPr lang="en-US" sz="1600" b="1" i="0">
-                <a:solidFill>
-                  <a:srgbClr val="1F3A5F"/>
-                </a:solidFill>
-              </a:rPr>
-              <a:t>Cluster 1 (n=3360)</a:t>
-            </a:r>
-          </a:p>
-          <a:p>
-            <a:pPr/>
-            <a:r>
-              <a:rPr lang="en-US" sz="1600" b="0" i="0">
-                <a:solidFill>
-                  <a:srgbClr val="555555"/>
-                </a:solidFill>
-              </a:rPr>
-              <a:t>distress rate 12.5%</a:t>
-            </a:r>
-          </a:p>
-          <a:p>
-            <a:pPr/>
-            <a:r>
-              <a:rPr lang="en-US" sz="1600" b="1" i="0">
-                <a:solidFill>
-                  <a:srgbClr val="1F3A5F"/>
-                </a:solidFill>
-              </a:rPr>
-              <a:t>Cluster 2 (n=2810)</a:t>
-            </a:r>
-          </a:p>
-          <a:p>
-            <a:pPr/>
-            <a:r>
-              <a:rPr lang="en-US" sz="1600" b="0" i="0">
-                <a:solidFill>
-                  <a:srgbClr val="555555"/>
-                </a:solidFill>
-              </a:rPr>
-              <a:t>distress rate 3.0%</a:t>
-            </a:r>
-          </a:p>
-          <a:p>
-            <a:pPr/>
-            <a:r>
-              <a:rPr lang="en-US" sz="1600" b="1" i="0">
-                <a:solidFill>
-                  <a:srgbClr val="1F3A5F"/>
-                </a:solidFill>
-              </a:rPr>
-              <a:t>Cluster 3 (n=2547)</a:t>
-            </a:r>
-          </a:p>
-          <a:p>
-            <a:pPr/>
-            <a:r>
-              <a:rPr lang="en-US" sz="1600" b="0" i="0">
-                <a:solidFill>
-                  <a:srgbClr val="555555"/>
-                </a:solidFill>
-              </a:rPr>
-              <a:t>distress rate 0.6%</a:t>
-            </a:r>
-          </a:p>
-          <a:p>
-            <a:pPr/>
-            <a:r>
-              <a:rPr lang="en-US" sz="1600" b="1" i="0">
-                <a:solidFill>
-                  <a:srgbClr val="1F3A5F"/>
-                </a:solidFill>
-              </a:rPr>
-              <a:t>Cluster 4 (n=1428)</a:t>
-            </a:r>
-          </a:p>
-          <a:p>
-            <a:pPr/>
-            <a:r>
-              <a:rPr lang="en-US" sz="1600" b="0" i="0">
-                <a:solidFill>
-                  <a:srgbClr val="555555"/>
-                </a:solidFill>
-              </a:rPr>
-              <a:t>distress rate 50.1%</a:t>
+              <a:t>Algorithm.</a:t>
+            </a:r>
+          </a:p>
+          <a:p>
+            <a:pPr/>
+            <a:r>
+              <a:rPr lang="en-US" sz="1600" b="0" i="0">
+                <a:solidFill>
+                  <a:srgbClr val="555555"/>
+                </a:solidFill>
+              </a:rPr>
+              <a:t>K-Means on standardized, log-transformed features.</a:t>
+            </a:r>
+          </a:p>
+          <a:p>
+            <a:pPr/>
+            <a:r>
+              <a:rPr lang="en-US" sz="1600" b="1" i="0">
+                <a:solidFill>
+                  <a:srgbClr val="1F3A5F"/>
+                </a:solidFill>
+              </a:rPr>
+              <a:t>Choosing k.</a:t>
+            </a:r>
+          </a:p>
+          <a:p>
+            <a:pPr/>
+            <a:r>
+              <a:rPr lang="en-US" sz="1600" b="0" i="0">
+                <a:solidFill>
+                  <a:srgbClr val="555555"/>
+                </a:solidFill>
+              </a:rPr>
+              <a:t>Silhouette over k=2..8 (max at k=2); K=5 selected for profiling granularity.</a:t>
+            </a:r>
+          </a:p>
+          <a:p>
+            <a:pPr/>
+            <a:r>
+              <a:rPr lang="en-US" sz="1600" b="1" i="0">
+                <a:solidFill>
+                  <a:srgbClr val="1F3A5F"/>
+                </a:solidFill>
+              </a:rPr>
+              <a:t>Result.</a:t>
+            </a:r>
+          </a:p>
+          <a:p>
+            <a:pPr/>
+            <a:r>
+              <a:rPr lang="en-US" sz="1600" b="0" i="0">
+                <a:solidFill>
+                  <a:srgbClr val="555555"/>
+                </a:solidFill>
+              </a:rPr>
+              <a:t>K = 5 clusters; silhouette at K=5 = 0.211.</a:t>
+            </a:r>
+          </a:p>
+          <a:p>
+            <a:pPr/>
+            <a:r>
+              <a:rPr lang="en-US" sz="1600" b="1" i="0">
+                <a:solidFill>
+                  <a:srgbClr val="1F3A5F"/>
+                </a:solidFill>
+              </a:rPr>
+              <a:t>Trade-off.</a:t>
+            </a:r>
+          </a:p>
+          <a:p>
+            <a:pPr/>
+            <a:r>
+              <a:rPr lang="en-US" sz="1600" b="0" i="0">
+                <a:solidFill>
+                  <a:srgbClr val="555555"/>
+                </a:solidFill>
+              </a:rPr>
+              <a:t>Separation vs interpretability: 5 segments are economically distinguishable.</a:t>
             </a:r>
           </a:p>
         </p:txBody>
@@ -1041,14 +1024,14 @@
           <p:nvPr/>
         </p:nvPicPr>
         <p:blipFill>
-          <a:blip r:embed="rId2"/>
+          <a:blip r:embed="rId1"/>
           <a:stretch>
             <a:fillRect/>
           </a:stretch>
         </p:blipFill>
         <p:spPr>
-          <a:off x="457200" y="1280160"/>
-          <a:ext cx="7680960" cy="4320540"/>
+          <a:off x="6400800" y="1463040"/>
+          <a:ext cx="5486400" cy="3086100"/>
           <a:noFill/>
         </p:spPr>
       </p:pic>
@@ -1119,7 +1102,7 @@
                   <a:srgbClr val="FFFFFF"/>
                 </a:solidFill>
               </a:rPr>
-              <a:t>Task A - Geographic Patterns</a:t>
+              <a:t>Task A - Cluster Profiles</a:t>
             </a:r>
           </a:p>
         </p:txBody>
@@ -1146,62 +1129,106 @@
                   <a:srgbClr val="1F3A5F"/>
                 </a:solidFill>
               </a:rPr>
-              <a:t>North-heavy.</a:t>
-            </a:r>
-          </a:p>
-          <a:p>
-            <a:pPr/>
-            <a:r>
-              <a:rPr lang="en-US" sz="1600" b="0" i="0">
-                <a:solidFill>
-                  <a:srgbClr val="555555"/>
-                </a:solidFill>
-              </a:rPr>
-              <a:t>Every cluster is dominated by the North/industrial belt.</a:t>
-            </a:r>
-          </a:p>
-          <a:p>
-            <a:pPr/>
-            <a:r>
-              <a:rPr lang="en-US" sz="1600" b="1" i="0">
-                <a:solidFill>
-                  <a:srgbClr val="1F3A5F"/>
-                </a:solidFill>
-              </a:rPr>
-              <a:t>Distress is uneven.</a:t>
-            </a:r>
-          </a:p>
-          <a:p>
-            <a:pPr/>
-            <a:r>
-              <a:rPr lang="en-US" sz="1600" b="0" i="0">
-                <a:solidFill>
-                  <a:srgbClr val="555555"/>
-                </a:solidFill>
-              </a:rPr>
-              <a:t>Cluster 4 carries ~50% distress; cluster 3 ~0.6%.</a:t>
-            </a:r>
-          </a:p>
-          <a:p>
-            <a:pPr/>
-            <a:r>
-              <a:rPr lang="en-US" sz="1600" b="1" i="0">
-                <a:solidFill>
-                  <a:srgbClr val="1F3A5F"/>
-                </a:solidFill>
-              </a:rPr>
-              <a:t>Islands under-represented.</a:t>
-            </a:r>
-          </a:p>
-          <a:p>
-            <a:pPr/>
-            <a:r>
-              <a:rPr lang="en-US" sz="1600" b="0" i="0">
-                <a:solidFill>
-                  <a:srgbClr val="555555"/>
-                </a:solidFill>
-              </a:rPr>
-              <a:t>Sicilia &amp; Sardegna are a small share in all clusters.</a:t>
+              <a:t>Cluster 0 (n=3828)</a:t>
+            </a:r>
+          </a:p>
+          <a:p>
+            <a:pPr/>
+            <a:r>
+              <a:rPr lang="en-US" sz="1600" b="0" i="0">
+                <a:solidFill>
+                  <a:srgbClr val="555555"/>
+                </a:solidFill>
+              </a:rPr>
+              <a:t>distress rate 7.0%</a:t>
+            </a:r>
+          </a:p>
+          <a:p>
+            <a:pPr/>
+            <a:r>
+              <a:rPr lang="en-US" sz="1600" b="1" i="0">
+                <a:solidFill>
+                  <a:srgbClr val="1F3A5F"/>
+                </a:solidFill>
+              </a:rPr>
+              <a:t>Cluster 1 (n=3328)</a:t>
+            </a:r>
+          </a:p>
+          <a:p>
+            <a:pPr/>
+            <a:r>
+              <a:rPr lang="en-US" sz="1600" b="0" i="0">
+                <a:solidFill>
+                  <a:srgbClr val="555555"/>
+                </a:solidFill>
+              </a:rPr>
+              <a:t>distress rate 12.6%</a:t>
+            </a:r>
+          </a:p>
+          <a:p>
+            <a:pPr/>
+            <a:r>
+              <a:rPr lang="en-US" sz="1600" b="1" i="0">
+                <a:solidFill>
+                  <a:srgbClr val="1F3A5F"/>
+                </a:solidFill>
+              </a:rPr>
+              <a:t>Cluster 2 (n=2849)</a:t>
+            </a:r>
+          </a:p>
+          <a:p>
+            <a:pPr/>
+            <a:r>
+              <a:rPr lang="en-US" sz="1600" b="0" i="0">
+                <a:solidFill>
+                  <a:srgbClr val="555555"/>
+                </a:solidFill>
+              </a:rPr>
+              <a:t>distress rate 3.0%</a:t>
+            </a:r>
+          </a:p>
+          <a:p>
+            <a:pPr/>
+            <a:r>
+              <a:rPr lang="en-US" sz="1600" b="1" i="0">
+                <a:solidFill>
+                  <a:srgbClr val="1F3A5F"/>
+                </a:solidFill>
+              </a:rPr>
+              <a:t>Cluster 3 (n=2449)</a:t>
+            </a:r>
+          </a:p>
+          <a:p>
+            <a:pPr/>
+            <a:r>
+              <a:rPr lang="en-US" sz="1600" b="0" i="0">
+                <a:solidFill>
+                  <a:srgbClr val="555555"/>
+                </a:solidFill>
+              </a:rPr>
+              <a:t>distress rate 0.7%</a:t>
+            </a:r>
+          </a:p>
+          <a:p>
+            <a:pPr/>
+            <a:r>
+              <a:rPr lang="en-US" sz="1600" b="1" i="0">
+                <a:solidFill>
+                  <a:srgbClr val="1F3A5F"/>
+                </a:solidFill>
+              </a:rPr>
+              <a:t>Cluster 4 (n=1417)</a:t>
+            </a:r>
+          </a:p>
+          <a:p>
+            <a:pPr/>
+            <a:r>
+              <a:rPr lang="en-US" sz="1600" b="0" i="0">
+                <a:solidFill>
+                  <a:srgbClr val="555555"/>
+                </a:solidFill>
+              </a:rPr>
+              <a:t>distress rate 50.5%</a:t>
             </a:r>
           </a:p>
         </p:txBody>
@@ -1213,32 +1240,14 @@
           <p:nvPr/>
         </p:nvPicPr>
         <p:blipFill>
-          <a:blip r:embed="rId3"/>
+          <a:blip r:embed="rId2"/>
           <a:stretch>
             <a:fillRect/>
           </a:stretch>
         </p:blipFill>
         <p:spPr>
-          <a:off x="365760" y="1371600"/>
-          <a:ext cx="6766560" cy="3806190"/>
-          <a:noFill/>
-        </p:spPr>
-      </p:pic>
-      <p:pic>
-        <p:nvPicPr>
-          <p:cNvPr id="3" name="pic"/>
-          <p:cNvPicPr/>
-          <p:nvPr/>
-        </p:nvPicPr>
-        <p:blipFill>
-          <a:blip r:embed="rId4"/>
-          <a:stretch>
-            <a:fillRect/>
-          </a:stretch>
-        </p:blipFill>
-        <p:spPr>
-          <a:off x="7315200" y="1371600"/>
-          <a:ext cx="4572000" cy="2571750"/>
+          <a:off x="457200" y="1280160"/>
+          <a:ext cx="7680960" cy="4320540"/>
           <a:noFill/>
         </p:spPr>
       </p:pic>
@@ -1309,7 +1318,7 @@
                   <a:srgbClr val="FFFFFF"/>
                 </a:solidFill>
               </a:rPr>
-              <a:t>Task B - Predicting Distress</a:t>
+              <a:t>Task A - Geographic Patterns</a:t>
             </a:r>
           </a:p>
         </p:txBody>
@@ -1336,128 +1345,62 @@
                   <a:srgbClr val="1F3A5F"/>
                 </a:solidFill>
               </a:rPr>
-              <a:t>Model.</a:t>
-            </a:r>
-          </a:p>
-          <a:p>
-            <a:pPr/>
-            <a:r>
-              <a:rPr lang="en-US" sz="1600" b="0" i="0">
-                <a:solidFill>
-                  <a:srgbClr val="555555"/>
-                </a:solidFill>
-              </a:rPr>
-              <a:t>Logistic Regression (L2, class-weighted) - robust baseline for early warning.</a:t>
-            </a:r>
-          </a:p>
-          <a:p>
-            <a:pPr/>
-            <a:r>
-              <a:rPr lang="en-US" sz="1600" b="1" i="0">
-                <a:solidFill>
-                  <a:srgbClr val="1F3A5F"/>
-                </a:solidFill>
-              </a:rPr>
-              <a:t>Cleaning.</a:t>
-            </a:r>
-          </a:p>
-          <a:p>
-            <a:pPr/>
-            <a:r>
-              <a:rPr lang="en-US" sz="1600" b="0" i="0">
-                <a:solidFill>
-                  <a:srgbClr val="555555"/>
-                </a:solidFill>
-              </a:rPr>
-              <a:t>Dropped 2 collinear derived vars (VIF 182-204) so coefficients are stable.</a:t>
-            </a:r>
-          </a:p>
-          <a:p>
-            <a:pPr/>
-            <a:r>
-              <a:rPr lang="en-US" sz="1600" b="1" i="0">
-                <a:solidFill>
-                  <a:srgbClr val="1F3A5F"/>
-                </a:solidFill>
-              </a:rPr>
-              <a:t>Validation.</a:t>
-            </a:r>
-          </a:p>
-          <a:p>
-            <a:pPr/>
-            <a:r>
-              <a:rPr lang="en-US" sz="1600" b="0" i="0">
-                <a:solidFill>
-                  <a:srgbClr val="555555"/>
-                </a:solidFill>
-              </a:rPr>
-              <a:t>5-fold stratified CV, ROC-AUC = 0.852 (+/- 0.008).</a:t>
-            </a:r>
-          </a:p>
-          <a:p>
-            <a:pPr/>
-            <a:r>
-              <a:rPr lang="en-US" sz="1600" b="1" i="0">
-                <a:solidFill>
-                  <a:srgbClr val="1F3A5F"/>
-                </a:solidFill>
-              </a:rPr>
-              <a:t>Train AUC.</a:t>
-            </a:r>
-          </a:p>
-          <a:p>
-            <a:pPr/>
-            <a:r>
-              <a:rPr lang="en-US" sz="1600" b="0" i="0">
-                <a:solidFill>
-                  <a:srgbClr val="555555"/>
-                </a:solidFill>
-              </a:rPr>
-              <a:t>0.856.</a:t>
-            </a:r>
-          </a:p>
-          <a:p>
-            <a:pPr/>
-            <a:r>
-              <a:rPr lang="en-US" sz="1600" b="1" i="0">
-                <a:solidFill>
-                  <a:srgbClr val="1F3A5F"/>
-                </a:solidFill>
-              </a:rPr>
-              <a:t>Deliverable.</a:t>
-            </a:r>
-          </a:p>
-          <a:p>
-            <a:pPr/>
-            <a:r>
-              <a:rPr lang="en-US" sz="1600" b="0" i="0">
-                <a:solidFill>
-                  <a:srgbClr val="555555"/>
-                </a:solidFill>
-              </a:rPr>
-              <a:t>predictions.csv: Company ID + pred_class (TRUE/FALSE).</a:t>
-            </a:r>
-          </a:p>
-          <a:p>
-            <a:pPr/>
-            <a:r>
-              <a:rPr lang="en-US" sz="1600" b="1" i="0">
-                <a:solidFill>
-                  <a:srgbClr val="1F3A5F"/>
-                </a:solidFill>
-              </a:rPr>
-              <a:t>Top drivers.</a:t>
-            </a:r>
-          </a:p>
-          <a:p>
-            <a:pPr/>
-            <a:r>
-              <a:rPr lang="en-US" sz="1600" b="0" i="0">
-                <a:solidFill>
-                  <a:srgbClr val="555555"/>
-                </a:solidFill>
-              </a:rPr>
-              <a:t>Operating Income, Net income, Total financial expenses, Operating cash flow.</a:t>
+              <a:t>North-heavy.</a:t>
+            </a:r>
+          </a:p>
+          <a:p>
+            <a:pPr/>
+            <a:r>
+              <a:rPr lang="en-US" sz="1600" b="0" i="0">
+                <a:solidFill>
+                  <a:srgbClr val="555555"/>
+                </a:solidFill>
+              </a:rPr>
+              <a:t>Every cluster is dominated by the North/industrial belt.</a:t>
+            </a:r>
+          </a:p>
+          <a:p>
+            <a:pPr/>
+            <a:r>
+              <a:rPr lang="en-US" sz="1600" b="1" i="0">
+                <a:solidFill>
+                  <a:srgbClr val="1F3A5F"/>
+                </a:solidFill>
+              </a:rPr>
+              <a:t>Distress is uneven.</a:t>
+            </a:r>
+          </a:p>
+          <a:p>
+            <a:pPr/>
+            <a:r>
+              <a:rPr lang="en-US" sz="1600" b="0" i="0">
+                <a:solidFill>
+                  <a:srgbClr val="555555"/>
+                </a:solidFill>
+              </a:rPr>
+              <a:t>Cluster 4 carries ~50% distress; cluster 3 ~0.6%.</a:t>
+            </a:r>
+          </a:p>
+          <a:p>
+            <a:pPr/>
+            <a:r>
+              <a:rPr lang="en-US" sz="1600" b="1" i="0">
+                <a:solidFill>
+                  <a:srgbClr val="1F3A5F"/>
+                </a:solidFill>
+              </a:rPr>
+              <a:t>Islands under-represented.</a:t>
+            </a:r>
+          </a:p>
+          <a:p>
+            <a:pPr/>
+            <a:r>
+              <a:rPr lang="en-US" sz="1600" b="0" i="0">
+                <a:solidFill>
+                  <a:srgbClr val="555555"/>
+                </a:solidFill>
+              </a:rPr>
+              <a:t>Sicilia &amp; Sardegna are a small share in all clusters.</a:t>
             </a:r>
           </a:p>
         </p:txBody>
@@ -1469,14 +1412,32 @@
           <p:nvPr/>
         </p:nvPicPr>
         <p:blipFill>
-          <a:blip r:embed="rId5"/>
+          <a:blip r:embed="rId3"/>
           <a:stretch>
             <a:fillRect/>
           </a:stretch>
         </p:blipFill>
         <p:spPr>
-          <a:off x="6400800" y="1371600"/>
-          <a:ext cx="5486400" cy="3086100"/>
+          <a:off x="365760" y="1371600"/>
+          <a:ext cx="6766560" cy="3806190"/>
+          <a:noFill/>
+        </p:spPr>
+      </p:pic>
+      <p:pic>
+        <p:nvPicPr>
+          <p:cNvPr id="3" name="pic"/>
+          <p:cNvPicPr/>
+          <p:nvPr/>
+        </p:nvPicPr>
+        <p:blipFill>
+          <a:blip r:embed="rId4"/>
+          <a:stretch>
+            <a:fillRect/>
+          </a:stretch>
+        </p:blipFill>
+        <p:spPr>
+          <a:off x="7315200" y="1371600"/>
+          <a:ext cx="4572000" cy="2571750"/>
           <a:noFill/>
         </p:spPr>
       </p:pic>
@@ -1489,6 +1450,244 @@
 </file>
 
 <file path=ppt/slides/slide8.xml><?xml version="1.0" encoding="utf-8"?>
+<p:sld xmlns:a="http://schemas.openxmlformats.org/drawingml/2006/main" xmlns:r="http://schemas.openxmlformats.org/officeDocument/2006/relationships" xmlns:p="http://schemas.openxmlformats.org/presentationml/2006/main">
+  <p:cSld>
+    <p:spTree>
+      <p:nvGrpSpPr>
+        <p:cNvPr id="0" name=""/>
+        <p:cNvGrpSpPr/>
+        <p:nvPr/>
+      </p:nvGrpSpPr>
+      <p:grpSpPr>
+        <a:off x="0" y="0"/>
+        <a:ext cx="0" cy="0"/>
+        <a:chOff x="0" y="0"/>
+        <a:chExt cx="0" cy="0"/>
+      </p:grpSpPr>
+      <p:sp>
+        <p:nvSpPr>
+          <p:cNvPr id="1" name="Rect"/>
+          <p:cNvSpPr/>
+          <p:nvPr/>
+        </p:nvSpPr>
+        <p:spPr>
+          <a:off x="0" y="0"/>
+          <a:ext cx="12191695" cy="1005840"/>
+          <a:solidFill>
+            <a:srgbClr val="1F3A5F"/>
+          </a:solidFill>
+          <a:ln>
+            <a:noFill/>
+          </a:ln>
+        </p:spPr>
+        <p:txBody>
+          <a:bodyPr/>
+          <a:lstStyle/>
+          <a:p/>
+        </p:txBody>
+      </p:sp>
+      <p:sp>
+        <p:nvSpPr>
+          <p:cNvPr id="2" name="TextBox"/>
+          <p:cNvSpPr txBox="1"/>
+          <p:nvPr/>
+        </p:nvSpPr>
+        <p:spPr>
+          <a:off x="457200" y="164592"/>
+          <a:ext cx="11247120" cy="731520"/>
+          <a:noFill/>
+        </p:spPr>
+        <p:txBody>
+          <a:bodyPr wrap="square" lIns="91440" tIns="45720" rIns="91440" bIns="45720"/>
+          <a:lstStyle/>
+          <a:p>
+            <a:pPr/>
+            <a:r>
+              <a:rPr lang="en-US" sz="2800" b="1" i="0">
+                <a:solidFill>
+                  <a:srgbClr val="FFFFFF"/>
+                </a:solidFill>
+              </a:rPr>
+              <a:t>Task B - Predicting Distress</a:t>
+            </a:r>
+          </a:p>
+        </p:txBody>
+      </p:sp>
+      <p:sp>
+        <p:nvSpPr>
+          <p:cNvPr id="2" name="TextBox"/>
+          <p:cNvSpPr txBox="1"/>
+          <p:nvPr/>
+        </p:nvSpPr>
+        <p:spPr>
+          <a:off x="640080" y="1325880"/>
+          <a:ext cx="10972800" cy="4572000"/>
+          <a:noFill/>
+        </p:spPr>
+        <p:txBody>
+          <a:bodyPr wrap="square" lIns="91440" tIns="45720" rIns="91440" bIns="45720"/>
+          <a:lstStyle/>
+          <a:p>
+            <a:pPr/>
+            <a:r>
+              <a:rPr lang="en-US" sz="1600" b="1" i="0">
+                <a:solidFill>
+                  <a:srgbClr val="1F3A5F"/>
+                </a:solidFill>
+              </a:rPr>
+              <a:t>Model.</a:t>
+            </a:r>
+          </a:p>
+          <a:p>
+            <a:pPr/>
+            <a:r>
+              <a:rPr lang="en-US" sz="1600" b="0" i="0">
+                <a:solidFill>
+                  <a:srgbClr val="555555"/>
+                </a:solidFill>
+              </a:rPr>
+              <a:t>Logistic Regression (L2, class-weighted) - robust baseline for early warning.</a:t>
+            </a:r>
+          </a:p>
+          <a:p>
+            <a:pPr/>
+            <a:r>
+              <a:rPr lang="en-US" sz="1600" b="1" i="0">
+                <a:solidFill>
+                  <a:srgbClr val="1F3A5F"/>
+                </a:solidFill>
+              </a:rPr>
+              <a:t>Cleaning.</a:t>
+            </a:r>
+          </a:p>
+          <a:p>
+            <a:pPr/>
+            <a:r>
+              <a:rPr lang="en-US" sz="1600" b="0" i="0">
+                <a:solidFill>
+                  <a:srgbClr val="555555"/>
+                </a:solidFill>
+              </a:rPr>
+              <a:t>Dropped 2 collinear derived vars (VIF 182-204) so coefficients are stable.</a:t>
+            </a:r>
+          </a:p>
+          <a:p>
+            <a:pPr/>
+            <a:r>
+              <a:rPr lang="en-US" sz="1600" b="1" i="0">
+                <a:solidFill>
+                  <a:srgbClr val="1F3A5F"/>
+                </a:solidFill>
+              </a:rPr>
+              <a:t>Validation.</a:t>
+            </a:r>
+          </a:p>
+          <a:p>
+            <a:pPr/>
+            <a:r>
+              <a:rPr lang="en-US" sz="1600" b="0" i="0">
+                <a:solidFill>
+                  <a:srgbClr val="555555"/>
+                </a:solidFill>
+              </a:rPr>
+              <a:t>5-fold stratified CV, ROC-AUC = 0.852 (+/- 0.016).</a:t>
+            </a:r>
+          </a:p>
+          <a:p>
+            <a:pPr/>
+            <a:r>
+              <a:rPr lang="en-US" sz="1600" b="1" i="0">
+                <a:solidFill>
+                  <a:srgbClr val="1F3A5F"/>
+                </a:solidFill>
+              </a:rPr>
+              <a:t>Train AUC.</a:t>
+            </a:r>
+          </a:p>
+          <a:p>
+            <a:pPr/>
+            <a:r>
+              <a:rPr lang="en-US" sz="1600" b="0" i="0">
+                <a:solidFill>
+                  <a:srgbClr val="555555"/>
+                </a:solidFill>
+              </a:rPr>
+              <a:t>0.856.</a:t>
+            </a:r>
+          </a:p>
+          <a:p>
+            <a:pPr/>
+            <a:r>
+              <a:rPr lang="en-US" sz="1600" b="1" i="0">
+                <a:solidFill>
+                  <a:srgbClr val="1F3A5F"/>
+                </a:solidFill>
+              </a:rPr>
+              <a:t>Deliverable.</a:t>
+            </a:r>
+          </a:p>
+          <a:p>
+            <a:pPr/>
+            <a:r>
+              <a:rPr lang="en-US" sz="1600" b="0" i="0">
+                <a:solidFill>
+                  <a:srgbClr val="555555"/>
+                </a:solidFill>
+              </a:rPr>
+              <a:t>predictions.csv: Company ID + pred_class (TRUE/FALSE).</a:t>
+            </a:r>
+          </a:p>
+          <a:p>
+            <a:pPr/>
+            <a:r>
+              <a:rPr lang="en-US" sz="1600" b="1" i="0">
+                <a:solidFill>
+                  <a:srgbClr val="1F3A5F"/>
+                </a:solidFill>
+              </a:rPr>
+              <a:t>Top drivers.</a:t>
+            </a:r>
+          </a:p>
+          <a:p>
+            <a:pPr/>
+            <a:r>
+              <a:rPr lang="en-US" sz="1600" b="0" i="0">
+                <a:solidFill>
+                  <a:srgbClr val="555555"/>
+                </a:solidFill>
+              </a:rPr>
+              <a:t>Operating Income, Net income, Total financial expenses, Operating cash flow.</a:t>
+            </a:r>
+          </a:p>
+        </p:txBody>
+      </p:sp>
+      <p:pic>
+        <p:nvPicPr>
+          <p:cNvPr id="3" name="pic"/>
+          <p:cNvPicPr/>
+          <p:nvPr/>
+        </p:nvPicPr>
+        <p:blipFill>
+          <a:blip r:embed="rId5"/>
+          <a:stretch>
+            <a:fillRect/>
+          </a:stretch>
+        </p:blipFill>
+        <p:spPr>
+          <a:off x="6400800" y="1371600"/>
+          <a:ext cx="5486400" cy="3086100"/>
+          <a:noFill/>
+        </p:spPr>
+      </p:pic>
+    </p:spTree>
+  </p:cSld>
+  <p:clrMapOvr>
+    <a:overrideClrMapping bg1="lt1" tx1="dk1" bg2="lt2" tx2="dk2" accent1="accent1" accent2="accent2" accent3="accent3" accent4="accent4" accent5="accent5" accent6="accent6" hlink="hlink" folHlink="folHlink"/>
+  </p:clrMapOvr>
+</p:sld>
+</file>
+
+<file path=ppt/slides/slide9.xml><?xml version="1.0" encoding="utf-8"?>
 <p:sld xmlns:a="http://schemas.openxmlformats.org/drawingml/2006/main" xmlns:r="http://schemas.openxmlformats.org/officeDocument/2006/relationships" xmlns:p="http://schemas.openxmlformats.org/presentationml/2006/main">
   <p:cSld>
     <p:spTree>

</xml_diff>

<commit_message>
Finalize variable selection: 5 significant non-derived predictors
- Alert Index identified as Net income / Total financial expenses (r=0.95) -> dropped
- Current taxes collinear with Operating Income (r=0.87) -> dropped
- Operating cash flow non-significant (Wald p=0.55) -> dropped
- 5-feature model: Sales, Employees, Net/Op income, TotFinExp; Wald all p<0.05; CV AUC 0.846
- added Wald test to metrics; updated REPORT.md + slides
</commit_message>
<xml_diff>
--- a/artifacts/IFCS_2026_presentation.pptx
+++ b/artifacts/IFCS_2026_presentation.pptx
@@ -781,40 +781,40 @@
                   <a:srgbClr val="1F3A5F"/>
                 </a:solidFill>
               </a:rPr>
-              <a:t>Multicollinearity.</a:t>
-            </a:r>
-          </a:p>
-          <a:p>
-            <a:pPr/>
-            <a:r>
-              <a:rPr lang="en-US" sz="1600" b="0" i="0">
-                <a:solidFill>
-                  <a:srgbClr val="555555"/>
-                </a:solidFill>
-              </a:rPr>
-              <a:t>VIF up to 204 (Max deductible ~ Operating Income); dropped 2 derived vars from the model.</a:t>
-            </a:r>
-          </a:p>
-          <a:p>
-            <a:pPr/>
-            <a:r>
-              <a:rPr lang="en-US" sz="1600" b="1" i="0">
-                <a:solidFill>
-                  <a:srgbClr val="1F3A5F"/>
-                </a:solidFill>
-              </a:rPr>
-              <a:t>Classifier features.</a:t>
-            </a:r>
-          </a:p>
-          <a:p>
-            <a:pPr/>
-            <a:r>
-              <a:rPr lang="en-US" sz="1600" b="0" i="0">
-                <a:solidFill>
-                  <a:srgbClr val="555555"/>
-                </a:solidFill>
-              </a:rPr>
-              <a:t>8 cleaned vars (Sales, Employees, Net/Op income, FinExp, OpCF, Taxes, Alert).</a:t>
+              <a:t>Derived vars dropped.</a:t>
+            </a:r>
+          </a:p>
+          <a:p>
+            <a:pPr/>
+            <a:r>
+              <a:rPr lang="en-US" sz="1600" b="0" i="0">
+                <a:solidFill>
+                  <a:srgbClr val="555555"/>
+                </a:solidFill>
+              </a:rPr>
+              <a:t>Max deductible, Tax shield, Alert Index (=NetInc/TotFinExp r=0.95), Current taxes (r=0.87 w/ OpInc).</a:t>
+            </a:r>
+          </a:p>
+          <a:p>
+            <a:pPr/>
+            <a:r>
+              <a:rPr lang="en-US" sz="1600" b="1" i="0">
+                <a:solidFill>
+                  <a:srgbClr val="1F3A5F"/>
+                </a:solidFill>
+              </a:rPr>
+              <a:t>Final model.</a:t>
+            </a:r>
+          </a:p>
+          <a:p>
+            <a:pPr/>
+            <a:r>
+              <a:rPr lang="en-US" sz="1600" b="0" i="0">
+                <a:solidFill>
+                  <a:srgbClr val="555555"/>
+                </a:solidFill>
+              </a:rPr>
+              <a:t>5 significant non-derived vars: Sales, Employees, Net/Op income, TotFinExp (Wald all p&lt;0.05; CV AUC 0.846).</a:t>
             </a:r>
           </a:p>
           <a:p>
@@ -836,7 +836,7 @@
                   <a:srgbClr val="555555"/>
                 </a:solidFill>
               </a:rPr>
-              <a:t>Same CV AUC (0.852) - removed rows were noise, not signal.</a:t>
+              <a:t>Cleaner model, same/higher AUC - removed vars were redundant noise.</a:t>
             </a:r>
           </a:p>
         </p:txBody>
@@ -1557,18 +1557,18 @@
                   <a:srgbClr val="1F3A5F"/>
                 </a:solidFill>
               </a:rPr>
-              <a:t>Cleaning.</a:t>
-            </a:r>
-          </a:p>
-          <a:p>
-            <a:pPr/>
-            <a:r>
-              <a:rPr lang="en-US" sz="1600" b="0" i="0">
-                <a:solidFill>
-                  <a:srgbClr val="555555"/>
-                </a:solidFill>
-              </a:rPr>
-              <a:t>Dropped 2 collinear derived vars (VIF 182-204) so coefficients are stable.</a:t>
+              <a:t>Features.</a:t>
+            </a:r>
+          </a:p>
+          <a:p>
+            <a:pPr/>
+            <a:r>
+              <a:rPr lang="en-US" sz="1600" b="0" i="0">
+                <a:solidFill>
+                  <a:srgbClr val="555555"/>
+                </a:solidFill>
+              </a:rPr>
+              <a:t>5 significant non-derived vars (Wald all p&lt;0.05); redundant derived vars dropped.</a:t>
             </a:r>
           </a:p>
           <a:p>
@@ -1590,7 +1590,7 @@
                   <a:srgbClr val="555555"/>
                 </a:solidFill>
               </a:rPr>
-              <a:t>5-fold stratified CV, ROC-AUC = 0.852 (+/- 0.016).</a:t>
+              <a:t>5-fold stratified CV, ROC-AUC = 0.853 (+/- 0.016).</a:t>
             </a:r>
           </a:p>
           <a:p>
@@ -1656,7 +1656,7 @@
                   <a:srgbClr val="555555"/>
                 </a:solidFill>
               </a:rPr>
-              <a:t>Operating Income, Net income, Total financial expenses, Operating cash flow.</a:t>
+              <a:t>Operating Income, Net income, Total financial expenses, Sales Revenue.</a:t>
             </a:r>
           </a:p>
         </p:txBody>
@@ -1828,7 +1828,7 @@
                   <a:srgbClr val="555555"/>
                 </a:solidFill>
               </a:rPr>
-              <a:t>Logistic model reaches CV ROC-AUC 0.852 - strong early-warning signal.</a:t>
+              <a:t>Logistic model reaches CV ROC-AUC 0.853 - strong early-warning signal.</a:t>
             </a:r>
           </a:p>
           <a:p>

</xml_diff>

<commit_message>
Transform Employees -> Sales/Employee productivity; final 4-feature model
- Employees redundant w/ Sales (r=0.52) -> replaced by Revenue per Employee (now Wald p=2.3e-4)
- Sales Revenue dropped (redundant once productivity in, p=0.60)
- final 4 significant non-derived vars, all p<0.001; CV AUC 0.853
- updated REPORT.md (selection table + rationale) and slides
</commit_message>
<xml_diff>
--- a/artifacts/IFCS_2026_presentation.pptx
+++ b/artifacts/IFCS_2026_presentation.pptx
@@ -814,7 +814,7 @@
                   <a:srgbClr val="555555"/>
                 </a:solidFill>
               </a:rPr>
-              <a:t>5 significant non-derived vars: Sales, Employees, Net/Op income, TotFinExp (Wald all p&lt;0.05; CV AUC 0.846).</a:t>
+              <a:t>4 significant non-derived vars: OpInc, NetInc, TotFinExp, Sales/Employee (productivity; Wald all p&lt;0.001; CV AUC 0.853).</a:t>
             </a:r>
           </a:p>
           <a:p>
@@ -1568,7 +1568,7 @@
                   <a:srgbClr val="555555"/>
                 </a:solidFill>
               </a:rPr>
-              <a:t>5 significant non-derived vars (Wald all p&lt;0.05); redundant derived vars dropped.</a:t>
+              <a:t>4 significant non-derived vars (Wald all p&lt;0.001): OpInc, NetInc, TotFinExp, productivity.</a:t>
             </a:r>
           </a:p>
           <a:p>
@@ -1590,7 +1590,7 @@
                   <a:srgbClr val="555555"/>
                 </a:solidFill>
               </a:rPr>
-              <a:t>5-fold stratified CV, ROC-AUC = 0.853 (+/- 0.016).</a:t>
+              <a:t>5-fold stratified CV, ROC-AUC = 0.853 (+/- 0.017).</a:t>
             </a:r>
           </a:p>
           <a:p>
@@ -1612,7 +1612,7 @@
                   <a:srgbClr val="555555"/>
                 </a:solidFill>
               </a:rPr>
-              <a:t>0.856.</a:t>
+              <a:t>0.855.</a:t>
             </a:r>
           </a:p>
           <a:p>
@@ -1656,7 +1656,7 @@
                   <a:srgbClr val="555555"/>
                 </a:solidFill>
               </a:rPr>
-              <a:t>Operating Income, Net income, Total financial expenses, Sales Revenue.</a:t>
+              <a:t>Operating Income, Net income, Total financial expenses, Rev_per_Employee.</a:t>
             </a:r>
           </a:p>
         </p:txBody>

</xml_diff>

<commit_message>
Add model comparison: LogReg vs RF vs GBM (k-fold + 80/20, P/R/F1/F2/AUC)
- hand-rolled RF and GBM in numpy (sklearn/xgb unavailable on Termux)
- 5-fold CV + holdout 80/20; metrics Precision/Recall/F1/F2/ROC-AUC
- Logistic Regression wins on F2 (0.564, recall 0.72) -> chosen for early-warning
- updated REPORT.md (comparison table + rationale) and slide Task B
</commit_message>
<xml_diff>
--- a/artifacts/IFCS_2026_presentation.pptx
+++ b/artifacts/IFCS_2026_presentation.pptx
@@ -1535,84 +1535,84 @@
                   <a:srgbClr val="1F3A5F"/>
                 </a:solidFill>
               </a:rPr>
-              <a:t>Model.</a:t>
-            </a:r>
-          </a:p>
-          <a:p>
-            <a:pPr/>
-            <a:r>
-              <a:rPr lang="en-US" sz="1600" b="0" i="0">
-                <a:solidFill>
-                  <a:srgbClr val="555555"/>
-                </a:solidFill>
-              </a:rPr>
-              <a:t>Logistic Regression (L2, class-weighted) - robust baseline for early warning.</a:t>
-            </a:r>
-          </a:p>
-          <a:p>
-            <a:pPr/>
-            <a:r>
-              <a:rPr lang="en-US" sz="1600" b="1" i="0">
-                <a:solidFill>
-                  <a:srgbClr val="1F3A5F"/>
-                </a:solidFill>
-              </a:rPr>
-              <a:t>Features.</a:t>
-            </a:r>
-          </a:p>
-          <a:p>
-            <a:pPr/>
-            <a:r>
-              <a:rPr lang="en-US" sz="1600" b="0" i="0">
-                <a:solidFill>
-                  <a:srgbClr val="555555"/>
-                </a:solidFill>
-              </a:rPr>
-              <a:t>4 significant non-derived vars (Wald all p&lt;0.001): OpInc, NetInc, TotFinExp, productivity.</a:t>
-            </a:r>
-          </a:p>
-          <a:p>
-            <a:pPr/>
-            <a:r>
-              <a:rPr lang="en-US" sz="1600" b="1" i="0">
-                <a:solidFill>
-                  <a:srgbClr val="1F3A5F"/>
-                </a:solidFill>
-              </a:rPr>
-              <a:t>Validation.</a:t>
-            </a:r>
-          </a:p>
-          <a:p>
-            <a:pPr/>
-            <a:r>
-              <a:rPr lang="en-US" sz="1600" b="0" i="0">
-                <a:solidFill>
-                  <a:srgbClr val="555555"/>
-                </a:solidFill>
-              </a:rPr>
-              <a:t>5-fold stratified CV, ROC-AUC = 0.853 (+/- 0.017).</a:t>
-            </a:r>
-          </a:p>
-          <a:p>
-            <a:pPr/>
-            <a:r>
-              <a:rPr lang="en-US" sz="1600" b="1" i="0">
-                <a:solidFill>
-                  <a:srgbClr val="1F3A5F"/>
-                </a:solidFill>
-              </a:rPr>
-              <a:t>Train AUC.</a:t>
-            </a:r>
-          </a:p>
-          <a:p>
-            <a:pPr/>
-            <a:r>
-              <a:rPr lang="en-US" sz="1600" b="0" i="0">
-                <a:solidFill>
-                  <a:srgbClr val="555555"/>
-                </a:solidFill>
-              </a:rPr>
-              <a:t>0.855.</a:t>
+              <a:t>Models compared.</a:t>
+            </a:r>
+          </a:p>
+          <a:p>
+            <a:pPr/>
+            <a:r>
+              <a:rPr lang="en-US" sz="1600" b="0" i="0">
+                <a:solidFill>
+                  <a:srgbClr val="555555"/>
+                </a:solidFill>
+              </a:rPr>
+              <a:t>LogReg (scipy), Random Forest &amp; GBM (numpy) - sklearn/xgb unavailable.</a:t>
+            </a:r>
+          </a:p>
+          <a:p>
+            <a:pPr/>
+            <a:r>
+              <a:rPr lang="en-US" sz="1600" b="1" i="0">
+                <a:solidFill>
+                  <a:srgbClr val="1F3A5F"/>
+                </a:solidFill>
+              </a:rPr>
+              <a:t>Eval.</a:t>
+            </a:r>
+          </a:p>
+          <a:p>
+            <a:pPr/>
+            <a:r>
+              <a:rPr lang="en-US" sz="1600" b="0" i="0">
+                <a:solidFill>
+                  <a:srgbClr val="555555"/>
+                </a:solidFill>
+              </a:rPr>
+              <a:t>5-fold CV + 80/20 holdout; Precision, Recall, F1, F2, ROC-AUC.</a:t>
+            </a:r>
+          </a:p>
+          <a:p>
+            <a:pPr/>
+            <a:r>
+              <a:rPr lang="en-US" sz="1600" b="1" i="0">
+                <a:solidFill>
+                  <a:srgbClr val="1F3A5F"/>
+                </a:solidFill>
+              </a:rPr>
+              <a:t>Winner.</a:t>
+            </a:r>
+          </a:p>
+          <a:p>
+            <a:pPr/>
+            <a:r>
+              <a:rPr lang="en-US" sz="1600" b="0" i="0">
+                <a:solidFill>
+                  <a:srgbClr val="555555"/>
+                </a:solidFill>
+              </a:rPr>
+              <a:t>Logistic Regression: highest F2 (0.564), AUC 0.857 ~ trees; recall 0.72.</a:t>
+            </a:r>
+          </a:p>
+          <a:p>
+            <a:pPr/>
+            <a:r>
+              <a:rPr lang="en-US" sz="1600" b="1" i="0">
+                <a:solidFill>
+                  <a:srgbClr val="1F3A5F"/>
+                </a:solidFill>
+              </a:rPr>
+              <a:t>Why.</a:t>
+            </a:r>
+          </a:p>
+          <a:p>
+            <a:pPr/>
+            <a:r>
+              <a:rPr lang="en-US" sz="1600" b="0" i="0">
+                <a:solidFill>
+                  <a:srgbClr val="555555"/>
+                </a:solidFill>
+              </a:rPr>
+              <a:t>F2 weights recall x2 - catching distressed firms matters most (false negative = costly).</a:t>
             </a:r>
           </a:p>
           <a:p>
@@ -1635,28 +1635,6 @@
                 </a:solidFill>
               </a:rPr>
               <a:t>predictions.csv: Company ID + pred_class (TRUE/FALSE).</a:t>
-            </a:r>
-          </a:p>
-          <a:p>
-            <a:pPr/>
-            <a:r>
-              <a:rPr lang="en-US" sz="1600" b="1" i="0">
-                <a:solidFill>
-                  <a:srgbClr val="1F3A5F"/>
-                </a:solidFill>
-              </a:rPr>
-              <a:t>Top drivers.</a:t>
-            </a:r>
-          </a:p>
-          <a:p>
-            <a:pPr/>
-            <a:r>
-              <a:rPr lang="en-US" sz="1600" b="0" i="0">
-                <a:solidFill>
-                  <a:srgbClr val="555555"/>
-                </a:solidFill>
-              </a:rPr>
-              <a:t>Operating Income, Net income, Total financial expenses, Rev_per_Employee.</a:t>
             </a:r>
           </a:p>
         </p:txBody>

</xml_diff>